<commit_message>
feat: embed 14 screenshots into training PPT
Captured fresh Playwright screenshots of all 11 pages.
Mapped to 14 slides (11 feature + 3 role):
- dashboard, portfolio, demand, products, epics, risks,
  releases, sprints, governance, users, config
- Admin→users, DL→demand, BA→governance

PPT size: 86KB → 1.7MB (image-embedded)
All screenshots in training/screenshots/ (1440×900)
</commit_message>
<xml_diff>
--- a/training/Training-PM-Tool.pptx
+++ b/training/Training-PM-Tool.pptx
@@ -3468,16 +3468,40 @@
           </a:p>
         </p:txBody>
       </p:sp>
-      <p:sp>
-        <p:nvSpPr>
-          <p:cNvPr id="5" name="TextBox 4"/>
-          <p:cNvSpPr txBox="1"/>
-          <p:nvPr/>
-        </p:nvSpPr>
-        <p:spPr>
-          <a:xfrm>
-            <a:off x="731520" y="1371600"/>
-            <a:ext cx="10698480" cy="5029200"/>
+      <p:pic>
+        <p:nvPicPr>
+          <p:cNvPr id="5" name="Picture 4" descr="demand.png"/>
+          <p:cNvPicPr>
+            <a:picLocks noChangeAspect="1"/>
+          </p:cNvPicPr>
+          <p:nvPr/>
+        </p:nvPicPr>
+        <p:blipFill>
+          <a:blip r:embed="rId2"/>
+          <a:stretch>
+            <a:fillRect/>
+          </a:stretch>
+        </p:blipFill>
+        <p:spPr>
+          <a:xfrm>
+            <a:off x="274320" y="1234440"/>
+            <a:ext cx="6858000" cy="5303520"/>
+          </a:xfrm>
+          <a:prstGeom prst="rect">
+            <a:avLst/>
+          </a:prstGeom>
+        </p:spPr>
+      </p:pic>
+      <p:sp>
+        <p:nvSpPr>
+          <p:cNvPr id="6" name="TextBox 5"/>
+          <p:cNvSpPr txBox="1"/>
+          <p:nvPr/>
+        </p:nvSpPr>
+        <p:spPr>
+          <a:xfrm>
+            <a:off x="7315200" y="1234440"/>
+            <a:ext cx="4572000" cy="5303520"/>
           </a:xfrm>
           <a:prstGeom prst="rect">
             <a:avLst/>
@@ -3492,9 +3516,9 @@
           <a:p>
             <a:pPr>
               <a:lnSpc>
-                <a:spcPts val="1900"/>
+                <a:spcPts val="1800"/>
               </a:lnSpc>
-              <a:defRPr sz="1300">
+              <a:defRPr sz="1200">
                 <a:solidFill>
                   <a:srgbClr val="0F172A"/>
                 </a:solidFill>
@@ -3575,7 +3599,7 @@
       </p:sp>
       <p:sp>
         <p:nvSpPr>
-          <p:cNvPr id="6" name="TextBox 5"/>
+          <p:cNvPr id="7" name="TextBox 6"/>
           <p:cNvSpPr txBox="1"/>
           <p:nvPr/>
         </p:nvSpPr>
@@ -3610,7 +3634,7 @@
       </p:sp>
       <p:sp>
         <p:nvSpPr>
-          <p:cNvPr id="7" name="TextBox 6"/>
+          <p:cNvPr id="8" name="TextBox 7"/>
           <p:cNvSpPr txBox="1"/>
           <p:nvPr/>
         </p:nvSpPr>
@@ -3782,16 +3806,40 @@
           </a:p>
         </p:txBody>
       </p:sp>
-      <p:sp>
-        <p:nvSpPr>
-          <p:cNvPr id="5" name="TextBox 4"/>
-          <p:cNvSpPr txBox="1"/>
-          <p:nvPr/>
-        </p:nvSpPr>
-        <p:spPr>
-          <a:xfrm>
-            <a:off x="731520" y="1371600"/>
-            <a:ext cx="10698480" cy="5029200"/>
+      <p:pic>
+        <p:nvPicPr>
+          <p:cNvPr id="5" name="Picture 4" descr="governance.png"/>
+          <p:cNvPicPr>
+            <a:picLocks noChangeAspect="1"/>
+          </p:cNvPicPr>
+          <p:nvPr/>
+        </p:nvPicPr>
+        <p:blipFill>
+          <a:blip r:embed="rId2"/>
+          <a:stretch>
+            <a:fillRect/>
+          </a:stretch>
+        </p:blipFill>
+        <p:spPr>
+          <a:xfrm>
+            <a:off x="274320" y="1234440"/>
+            <a:ext cx="6858000" cy="5303520"/>
+          </a:xfrm>
+          <a:prstGeom prst="rect">
+            <a:avLst/>
+          </a:prstGeom>
+        </p:spPr>
+      </p:pic>
+      <p:sp>
+        <p:nvSpPr>
+          <p:cNvPr id="6" name="TextBox 5"/>
+          <p:cNvSpPr txBox="1"/>
+          <p:nvPr/>
+        </p:nvSpPr>
+        <p:spPr>
+          <a:xfrm>
+            <a:off x="7315200" y="1234440"/>
+            <a:ext cx="4572000" cy="5303520"/>
           </a:xfrm>
           <a:prstGeom prst="rect">
             <a:avLst/>
@@ -3806,9 +3854,9 @@
           <a:p>
             <a:pPr>
               <a:lnSpc>
-                <a:spcPts val="1900"/>
+                <a:spcPts val="1800"/>
               </a:lnSpc>
-              <a:defRPr sz="1300">
+              <a:defRPr sz="1200">
                 <a:solidFill>
                   <a:srgbClr val="0F172A"/>
                 </a:solidFill>
@@ -3889,7 +3937,7 @@
       </p:sp>
       <p:sp>
         <p:nvSpPr>
-          <p:cNvPr id="6" name="TextBox 5"/>
+          <p:cNvPr id="7" name="TextBox 6"/>
           <p:cNvSpPr txBox="1"/>
           <p:nvPr/>
         </p:nvSpPr>
@@ -3924,7 +3972,7 @@
       </p:sp>
       <p:sp>
         <p:nvSpPr>
-          <p:cNvPr id="7" name="TextBox 6"/>
+          <p:cNvPr id="8" name="TextBox 7"/>
           <p:cNvSpPr txBox="1"/>
           <p:nvPr/>
         </p:nvSpPr>
@@ -4716,16 +4764,40 @@
           </a:p>
         </p:txBody>
       </p:sp>
-      <p:sp>
-        <p:nvSpPr>
-          <p:cNvPr id="5" name="TextBox 4"/>
-          <p:cNvSpPr txBox="1"/>
-          <p:nvPr/>
-        </p:nvSpPr>
-        <p:spPr>
-          <a:xfrm>
-            <a:off x="731520" y="1371600"/>
-            <a:ext cx="10698480" cy="5029200"/>
+      <p:pic>
+        <p:nvPicPr>
+          <p:cNvPr id="5" name="Picture 4" descr="dashboard.png"/>
+          <p:cNvPicPr>
+            <a:picLocks noChangeAspect="1"/>
+          </p:cNvPicPr>
+          <p:nvPr/>
+        </p:nvPicPr>
+        <p:blipFill>
+          <a:blip r:embed="rId2"/>
+          <a:stretch>
+            <a:fillRect/>
+          </a:stretch>
+        </p:blipFill>
+        <p:spPr>
+          <a:xfrm>
+            <a:off x="274320" y="1234440"/>
+            <a:ext cx="6858000" cy="5303520"/>
+          </a:xfrm>
+          <a:prstGeom prst="rect">
+            <a:avLst/>
+          </a:prstGeom>
+        </p:spPr>
+      </p:pic>
+      <p:sp>
+        <p:nvSpPr>
+          <p:cNvPr id="6" name="TextBox 5"/>
+          <p:cNvSpPr txBox="1"/>
+          <p:nvPr/>
+        </p:nvSpPr>
+        <p:spPr>
+          <a:xfrm>
+            <a:off x="7315200" y="1234440"/>
+            <a:ext cx="4572000" cy="5303520"/>
           </a:xfrm>
           <a:prstGeom prst="rect">
             <a:avLst/>
@@ -4740,9 +4812,9 @@
           <a:p>
             <a:pPr>
               <a:lnSpc>
-                <a:spcPts val="1900"/>
+                <a:spcPts val="1800"/>
               </a:lnSpc>
-              <a:defRPr sz="1300">
+              <a:defRPr sz="1200">
                 <a:solidFill>
                   <a:srgbClr val="0F172A"/>
                 </a:solidFill>
@@ -4803,7 +4875,7 @@
       </p:sp>
       <p:sp>
         <p:nvSpPr>
-          <p:cNvPr id="6" name="TextBox 5"/>
+          <p:cNvPr id="7" name="TextBox 6"/>
           <p:cNvSpPr txBox="1"/>
           <p:nvPr/>
         </p:nvSpPr>
@@ -4838,7 +4910,7 @@
       </p:sp>
       <p:sp>
         <p:nvSpPr>
-          <p:cNvPr id="7" name="TextBox 6"/>
+          <p:cNvPr id="8" name="TextBox 7"/>
           <p:cNvSpPr txBox="1"/>
           <p:nvPr/>
         </p:nvSpPr>
@@ -5010,16 +5082,40 @@
           </a:p>
         </p:txBody>
       </p:sp>
-      <p:sp>
-        <p:nvSpPr>
-          <p:cNvPr id="5" name="TextBox 4"/>
-          <p:cNvSpPr txBox="1"/>
-          <p:nvPr/>
-        </p:nvSpPr>
-        <p:spPr>
-          <a:xfrm>
-            <a:off x="731520" y="1371600"/>
-            <a:ext cx="10698480" cy="5029200"/>
+      <p:pic>
+        <p:nvPicPr>
+          <p:cNvPr id="5" name="Picture 4" descr="portfolio.png"/>
+          <p:cNvPicPr>
+            <a:picLocks noChangeAspect="1"/>
+          </p:cNvPicPr>
+          <p:nvPr/>
+        </p:nvPicPr>
+        <p:blipFill>
+          <a:blip r:embed="rId2"/>
+          <a:stretch>
+            <a:fillRect/>
+          </a:stretch>
+        </p:blipFill>
+        <p:spPr>
+          <a:xfrm>
+            <a:off x="274320" y="1234440"/>
+            <a:ext cx="6858000" cy="5303520"/>
+          </a:xfrm>
+          <a:prstGeom prst="rect">
+            <a:avLst/>
+          </a:prstGeom>
+        </p:spPr>
+      </p:pic>
+      <p:sp>
+        <p:nvSpPr>
+          <p:cNvPr id="6" name="TextBox 5"/>
+          <p:cNvSpPr txBox="1"/>
+          <p:nvPr/>
+        </p:nvSpPr>
+        <p:spPr>
+          <a:xfrm>
+            <a:off x="7315200" y="1234440"/>
+            <a:ext cx="4572000" cy="5303520"/>
           </a:xfrm>
           <a:prstGeom prst="rect">
             <a:avLst/>
@@ -5034,9 +5130,9 @@
           <a:p>
             <a:pPr>
               <a:lnSpc>
-                <a:spcPts val="1900"/>
+                <a:spcPts val="1800"/>
               </a:lnSpc>
-              <a:defRPr sz="1300">
+              <a:defRPr sz="1200">
                 <a:solidFill>
                   <a:srgbClr val="0F172A"/>
                 </a:solidFill>
@@ -5110,7 +5206,7 @@
       </p:sp>
       <p:sp>
         <p:nvSpPr>
-          <p:cNvPr id="6" name="TextBox 5"/>
+          <p:cNvPr id="7" name="TextBox 6"/>
           <p:cNvSpPr txBox="1"/>
           <p:nvPr/>
         </p:nvSpPr>
@@ -5145,7 +5241,7 @@
       </p:sp>
       <p:sp>
         <p:nvSpPr>
-          <p:cNvPr id="7" name="TextBox 6"/>
+          <p:cNvPr id="8" name="TextBox 7"/>
           <p:cNvSpPr txBox="1"/>
           <p:nvPr/>
         </p:nvSpPr>
@@ -5317,16 +5413,40 @@
           </a:p>
         </p:txBody>
       </p:sp>
-      <p:sp>
-        <p:nvSpPr>
-          <p:cNvPr id="5" name="TextBox 4"/>
-          <p:cNvSpPr txBox="1"/>
-          <p:nvPr/>
-        </p:nvSpPr>
-        <p:spPr>
-          <a:xfrm>
-            <a:off x="731520" y="1371600"/>
-            <a:ext cx="10698480" cy="5029200"/>
+      <p:pic>
+        <p:nvPicPr>
+          <p:cNvPr id="5" name="Picture 4" descr="demand.png"/>
+          <p:cNvPicPr>
+            <a:picLocks noChangeAspect="1"/>
+          </p:cNvPicPr>
+          <p:nvPr/>
+        </p:nvPicPr>
+        <p:blipFill>
+          <a:blip r:embed="rId2"/>
+          <a:stretch>
+            <a:fillRect/>
+          </a:stretch>
+        </p:blipFill>
+        <p:spPr>
+          <a:xfrm>
+            <a:off x="274320" y="1234440"/>
+            <a:ext cx="6858000" cy="5303520"/>
+          </a:xfrm>
+          <a:prstGeom prst="rect">
+            <a:avLst/>
+          </a:prstGeom>
+        </p:spPr>
+      </p:pic>
+      <p:sp>
+        <p:nvSpPr>
+          <p:cNvPr id="6" name="TextBox 5"/>
+          <p:cNvSpPr txBox="1"/>
+          <p:nvPr/>
+        </p:nvSpPr>
+        <p:spPr>
+          <a:xfrm>
+            <a:off x="7315200" y="1234440"/>
+            <a:ext cx="4572000" cy="5303520"/>
           </a:xfrm>
           <a:prstGeom prst="rect">
             <a:avLst/>
@@ -5341,9 +5461,9 @@
           <a:p>
             <a:pPr>
               <a:lnSpc>
-                <a:spcPts val="1900"/>
+                <a:spcPts val="1800"/>
               </a:lnSpc>
-              <a:defRPr sz="1300">
+              <a:defRPr sz="1200">
                 <a:solidFill>
                   <a:srgbClr val="0F172A"/>
                 </a:solidFill>
@@ -5417,7 +5537,7 @@
       </p:sp>
       <p:sp>
         <p:nvSpPr>
-          <p:cNvPr id="6" name="TextBox 5"/>
+          <p:cNvPr id="7" name="TextBox 6"/>
           <p:cNvSpPr txBox="1"/>
           <p:nvPr/>
         </p:nvSpPr>
@@ -5452,7 +5572,7 @@
       </p:sp>
       <p:sp>
         <p:nvSpPr>
-          <p:cNvPr id="7" name="TextBox 6"/>
+          <p:cNvPr id="8" name="TextBox 7"/>
           <p:cNvSpPr txBox="1"/>
           <p:nvPr/>
         </p:nvSpPr>
@@ -7876,16 +7996,40 @@
           </a:p>
         </p:txBody>
       </p:sp>
-      <p:sp>
-        <p:nvSpPr>
-          <p:cNvPr id="5" name="TextBox 4"/>
-          <p:cNvSpPr txBox="1"/>
-          <p:nvPr/>
-        </p:nvSpPr>
-        <p:spPr>
-          <a:xfrm>
-            <a:off x="731520" y="1371600"/>
-            <a:ext cx="10698480" cy="5029200"/>
+      <p:pic>
+        <p:nvPicPr>
+          <p:cNvPr id="5" name="Picture 4" descr="products.png"/>
+          <p:cNvPicPr>
+            <a:picLocks noChangeAspect="1"/>
+          </p:cNvPicPr>
+          <p:nvPr/>
+        </p:nvPicPr>
+        <p:blipFill>
+          <a:blip r:embed="rId2"/>
+          <a:stretch>
+            <a:fillRect/>
+          </a:stretch>
+        </p:blipFill>
+        <p:spPr>
+          <a:xfrm>
+            <a:off x="274320" y="1234440"/>
+            <a:ext cx="6858000" cy="5303520"/>
+          </a:xfrm>
+          <a:prstGeom prst="rect">
+            <a:avLst/>
+          </a:prstGeom>
+        </p:spPr>
+      </p:pic>
+      <p:sp>
+        <p:nvSpPr>
+          <p:cNvPr id="6" name="TextBox 5"/>
+          <p:cNvSpPr txBox="1"/>
+          <p:nvPr/>
+        </p:nvSpPr>
+        <p:spPr>
+          <a:xfrm>
+            <a:off x="7315200" y="1234440"/>
+            <a:ext cx="4572000" cy="5303520"/>
           </a:xfrm>
           <a:prstGeom prst="rect">
             <a:avLst/>
@@ -7900,9 +8044,9 @@
           <a:p>
             <a:pPr>
               <a:lnSpc>
-                <a:spcPts val="1900"/>
+                <a:spcPts val="1800"/>
               </a:lnSpc>
-              <a:defRPr sz="1300">
+              <a:defRPr sz="1200">
                 <a:solidFill>
                   <a:srgbClr val="0F172A"/>
                 </a:solidFill>
@@ -7963,7 +8107,7 @@
       </p:sp>
       <p:sp>
         <p:nvSpPr>
-          <p:cNvPr id="6" name="TextBox 5"/>
+          <p:cNvPr id="7" name="TextBox 6"/>
           <p:cNvSpPr txBox="1"/>
           <p:nvPr/>
         </p:nvSpPr>
@@ -7998,7 +8142,7 @@
       </p:sp>
       <p:sp>
         <p:nvSpPr>
-          <p:cNvPr id="7" name="TextBox 6"/>
+          <p:cNvPr id="8" name="TextBox 7"/>
           <p:cNvSpPr txBox="1"/>
           <p:nvPr/>
         </p:nvSpPr>
@@ -9012,16 +9156,40 @@
           </a:p>
         </p:txBody>
       </p:sp>
-      <p:sp>
-        <p:nvSpPr>
-          <p:cNvPr id="5" name="TextBox 4"/>
-          <p:cNvSpPr txBox="1"/>
-          <p:nvPr/>
-        </p:nvSpPr>
-        <p:spPr>
-          <a:xfrm>
-            <a:off x="731520" y="1371600"/>
-            <a:ext cx="10698480" cy="5029200"/>
+      <p:pic>
+        <p:nvPicPr>
+          <p:cNvPr id="5" name="Picture 4" descr="epics.png"/>
+          <p:cNvPicPr>
+            <a:picLocks noChangeAspect="1"/>
+          </p:cNvPicPr>
+          <p:nvPr/>
+        </p:nvPicPr>
+        <p:blipFill>
+          <a:blip r:embed="rId2"/>
+          <a:stretch>
+            <a:fillRect/>
+          </a:stretch>
+        </p:blipFill>
+        <p:spPr>
+          <a:xfrm>
+            <a:off x="274320" y="1234440"/>
+            <a:ext cx="6858000" cy="5303520"/>
+          </a:xfrm>
+          <a:prstGeom prst="rect">
+            <a:avLst/>
+          </a:prstGeom>
+        </p:spPr>
+      </p:pic>
+      <p:sp>
+        <p:nvSpPr>
+          <p:cNvPr id="6" name="TextBox 5"/>
+          <p:cNvSpPr txBox="1"/>
+          <p:nvPr/>
+        </p:nvSpPr>
+        <p:spPr>
+          <a:xfrm>
+            <a:off x="7315200" y="1234440"/>
+            <a:ext cx="4572000" cy="5303520"/>
           </a:xfrm>
           <a:prstGeom prst="rect">
             <a:avLst/>
@@ -9036,9 +9204,9 @@
           <a:p>
             <a:pPr>
               <a:lnSpc>
-                <a:spcPts val="1900"/>
+                <a:spcPts val="1800"/>
               </a:lnSpc>
-              <a:defRPr sz="1300">
+              <a:defRPr sz="1200">
                 <a:solidFill>
                   <a:srgbClr val="0F172A"/>
                 </a:solidFill>
@@ -9107,7 +9275,7 @@
       </p:sp>
       <p:sp>
         <p:nvSpPr>
-          <p:cNvPr id="6" name="TextBox 5"/>
+          <p:cNvPr id="7" name="TextBox 6"/>
           <p:cNvSpPr txBox="1"/>
           <p:nvPr/>
         </p:nvSpPr>
@@ -9142,7 +9310,7 @@
       </p:sp>
       <p:sp>
         <p:nvSpPr>
-          <p:cNvPr id="7" name="TextBox 6"/>
+          <p:cNvPr id="8" name="TextBox 7"/>
           <p:cNvSpPr txBox="1"/>
           <p:nvPr/>
         </p:nvSpPr>
@@ -9617,16 +9785,40 @@
           </a:p>
         </p:txBody>
       </p:sp>
-      <p:sp>
-        <p:nvSpPr>
-          <p:cNvPr id="5" name="TextBox 4"/>
-          <p:cNvSpPr txBox="1"/>
-          <p:nvPr/>
-        </p:nvSpPr>
-        <p:spPr>
-          <a:xfrm>
-            <a:off x="731520" y="1371600"/>
-            <a:ext cx="10698480" cy="5029200"/>
+      <p:pic>
+        <p:nvPicPr>
+          <p:cNvPr id="5" name="Picture 4" descr="risks.png"/>
+          <p:cNvPicPr>
+            <a:picLocks noChangeAspect="1"/>
+          </p:cNvPicPr>
+          <p:nvPr/>
+        </p:nvPicPr>
+        <p:blipFill>
+          <a:blip r:embed="rId2"/>
+          <a:stretch>
+            <a:fillRect/>
+          </a:stretch>
+        </p:blipFill>
+        <p:spPr>
+          <a:xfrm>
+            <a:off x="274320" y="1234440"/>
+            <a:ext cx="6858000" cy="5303520"/>
+          </a:xfrm>
+          <a:prstGeom prst="rect">
+            <a:avLst/>
+          </a:prstGeom>
+        </p:spPr>
+      </p:pic>
+      <p:sp>
+        <p:nvSpPr>
+          <p:cNvPr id="6" name="TextBox 5"/>
+          <p:cNvSpPr txBox="1"/>
+          <p:nvPr/>
+        </p:nvSpPr>
+        <p:spPr>
+          <a:xfrm>
+            <a:off x="7315200" y="1234440"/>
+            <a:ext cx="4572000" cy="5303520"/>
           </a:xfrm>
           <a:prstGeom prst="rect">
             <a:avLst/>
@@ -9641,9 +9833,9 @@
           <a:p>
             <a:pPr>
               <a:lnSpc>
-                <a:spcPts val="1900"/>
+                <a:spcPts val="1800"/>
               </a:lnSpc>
-              <a:defRPr sz="1300">
+              <a:defRPr sz="1200">
                 <a:solidFill>
                   <a:srgbClr val="0F172A"/>
                 </a:solidFill>
@@ -9696,7 +9888,7 @@
       </p:sp>
       <p:sp>
         <p:nvSpPr>
-          <p:cNvPr id="6" name="TextBox 5"/>
+          <p:cNvPr id="7" name="TextBox 6"/>
           <p:cNvSpPr txBox="1"/>
           <p:nvPr/>
         </p:nvSpPr>
@@ -9731,7 +9923,7 @@
       </p:sp>
       <p:sp>
         <p:nvSpPr>
-          <p:cNvPr id="7" name="TextBox 6"/>
+          <p:cNvPr id="8" name="TextBox 7"/>
           <p:cNvSpPr txBox="1"/>
           <p:nvPr/>
         </p:nvSpPr>
@@ -10189,16 +10381,40 @@
           </a:p>
         </p:txBody>
       </p:sp>
-      <p:sp>
-        <p:nvSpPr>
-          <p:cNvPr id="5" name="TextBox 4"/>
-          <p:cNvSpPr txBox="1"/>
-          <p:nvPr/>
-        </p:nvSpPr>
-        <p:spPr>
-          <a:xfrm>
-            <a:off x="731520" y="1371600"/>
-            <a:ext cx="10698480" cy="5029200"/>
+      <p:pic>
+        <p:nvPicPr>
+          <p:cNvPr id="5" name="Picture 4" descr="releases.png"/>
+          <p:cNvPicPr>
+            <a:picLocks noChangeAspect="1"/>
+          </p:cNvPicPr>
+          <p:nvPr/>
+        </p:nvPicPr>
+        <p:blipFill>
+          <a:blip r:embed="rId2"/>
+          <a:stretch>
+            <a:fillRect/>
+          </a:stretch>
+        </p:blipFill>
+        <p:spPr>
+          <a:xfrm>
+            <a:off x="274320" y="1234440"/>
+            <a:ext cx="6858000" cy="5303520"/>
+          </a:xfrm>
+          <a:prstGeom prst="rect">
+            <a:avLst/>
+          </a:prstGeom>
+        </p:spPr>
+      </p:pic>
+      <p:sp>
+        <p:nvSpPr>
+          <p:cNvPr id="6" name="TextBox 5"/>
+          <p:cNvSpPr txBox="1"/>
+          <p:nvPr/>
+        </p:nvSpPr>
+        <p:spPr>
+          <a:xfrm>
+            <a:off x="7315200" y="1234440"/>
+            <a:ext cx="4572000" cy="5303520"/>
           </a:xfrm>
           <a:prstGeom prst="rect">
             <a:avLst/>
@@ -10213,9 +10429,9 @@
           <a:p>
             <a:pPr>
               <a:lnSpc>
-                <a:spcPts val="1900"/>
+                <a:spcPts val="1800"/>
               </a:lnSpc>
-              <a:defRPr sz="1300">
+              <a:defRPr sz="1200">
                 <a:solidFill>
                   <a:srgbClr val="0F172A"/>
                 </a:solidFill>
@@ -10282,7 +10498,7 @@
       </p:sp>
       <p:sp>
         <p:nvSpPr>
-          <p:cNvPr id="6" name="TextBox 5"/>
+          <p:cNvPr id="7" name="TextBox 6"/>
           <p:cNvSpPr txBox="1"/>
           <p:nvPr/>
         </p:nvSpPr>
@@ -10317,7 +10533,7 @@
       </p:sp>
       <p:sp>
         <p:nvSpPr>
-          <p:cNvPr id="7" name="TextBox 6"/>
+          <p:cNvPr id="8" name="TextBox 7"/>
           <p:cNvSpPr txBox="1"/>
           <p:nvPr/>
         </p:nvSpPr>
@@ -10489,16 +10705,40 @@
           </a:p>
         </p:txBody>
       </p:sp>
-      <p:sp>
-        <p:nvSpPr>
-          <p:cNvPr id="5" name="TextBox 4"/>
-          <p:cNvSpPr txBox="1"/>
-          <p:nvPr/>
-        </p:nvSpPr>
-        <p:spPr>
-          <a:xfrm>
-            <a:off x="731520" y="1371600"/>
-            <a:ext cx="10698480" cy="5029200"/>
+      <p:pic>
+        <p:nvPicPr>
+          <p:cNvPr id="5" name="Picture 4" descr="sprints.png"/>
+          <p:cNvPicPr>
+            <a:picLocks noChangeAspect="1"/>
+          </p:cNvPicPr>
+          <p:nvPr/>
+        </p:nvPicPr>
+        <p:blipFill>
+          <a:blip r:embed="rId2"/>
+          <a:stretch>
+            <a:fillRect/>
+          </a:stretch>
+        </p:blipFill>
+        <p:spPr>
+          <a:xfrm>
+            <a:off x="274320" y="1234440"/>
+            <a:ext cx="6858000" cy="5303520"/>
+          </a:xfrm>
+          <a:prstGeom prst="rect">
+            <a:avLst/>
+          </a:prstGeom>
+        </p:spPr>
+      </p:pic>
+      <p:sp>
+        <p:nvSpPr>
+          <p:cNvPr id="6" name="TextBox 5"/>
+          <p:cNvSpPr txBox="1"/>
+          <p:nvPr/>
+        </p:nvSpPr>
+        <p:spPr>
+          <a:xfrm>
+            <a:off x="7315200" y="1234440"/>
+            <a:ext cx="4572000" cy="5303520"/>
           </a:xfrm>
           <a:prstGeom prst="rect">
             <a:avLst/>
@@ -10513,9 +10753,9 @@
           <a:p>
             <a:pPr>
               <a:lnSpc>
-                <a:spcPts val="1900"/>
+                <a:spcPts val="1800"/>
               </a:lnSpc>
-              <a:defRPr sz="1300">
+              <a:defRPr sz="1200">
                 <a:solidFill>
                   <a:srgbClr val="0F172A"/>
                 </a:solidFill>
@@ -10593,7 +10833,7 @@
       </p:sp>
       <p:sp>
         <p:nvSpPr>
-          <p:cNvPr id="6" name="TextBox 5"/>
+          <p:cNvPr id="7" name="TextBox 6"/>
           <p:cNvSpPr txBox="1"/>
           <p:nvPr/>
         </p:nvSpPr>
@@ -10628,7 +10868,7 @@
       </p:sp>
       <p:sp>
         <p:nvSpPr>
-          <p:cNvPr id="7" name="TextBox 6"/>
+          <p:cNvPr id="8" name="TextBox 7"/>
           <p:cNvSpPr txBox="1"/>
           <p:nvPr/>
         </p:nvSpPr>
@@ -10800,16 +11040,40 @@
           </a:p>
         </p:txBody>
       </p:sp>
-      <p:sp>
-        <p:nvSpPr>
-          <p:cNvPr id="5" name="TextBox 4"/>
-          <p:cNvSpPr txBox="1"/>
-          <p:nvPr/>
-        </p:nvSpPr>
-        <p:spPr>
-          <a:xfrm>
-            <a:off x="731520" y="1371600"/>
-            <a:ext cx="10698480" cy="5029200"/>
+      <p:pic>
+        <p:nvPicPr>
+          <p:cNvPr id="5" name="Picture 4" descr="governance.png"/>
+          <p:cNvPicPr>
+            <a:picLocks noChangeAspect="1"/>
+          </p:cNvPicPr>
+          <p:nvPr/>
+        </p:nvPicPr>
+        <p:blipFill>
+          <a:blip r:embed="rId2"/>
+          <a:stretch>
+            <a:fillRect/>
+          </a:stretch>
+        </p:blipFill>
+        <p:spPr>
+          <a:xfrm>
+            <a:off x="274320" y="1234440"/>
+            <a:ext cx="6858000" cy="5303520"/>
+          </a:xfrm>
+          <a:prstGeom prst="rect">
+            <a:avLst/>
+          </a:prstGeom>
+        </p:spPr>
+      </p:pic>
+      <p:sp>
+        <p:nvSpPr>
+          <p:cNvPr id="6" name="TextBox 5"/>
+          <p:cNvSpPr txBox="1"/>
+          <p:nvPr/>
+        </p:nvSpPr>
+        <p:spPr>
+          <a:xfrm>
+            <a:off x="7315200" y="1234440"/>
+            <a:ext cx="4572000" cy="5303520"/>
           </a:xfrm>
           <a:prstGeom prst="rect">
             <a:avLst/>
@@ -10824,9 +11088,9 @@
           <a:p>
             <a:pPr>
               <a:lnSpc>
-                <a:spcPts val="1900"/>
+                <a:spcPts val="1800"/>
               </a:lnSpc>
-              <a:defRPr sz="1300">
+              <a:defRPr sz="1200">
                 <a:solidFill>
                   <a:srgbClr val="0F172A"/>
                 </a:solidFill>
@@ -10900,7 +11164,7 @@
       </p:sp>
       <p:sp>
         <p:nvSpPr>
-          <p:cNvPr id="6" name="TextBox 5"/>
+          <p:cNvPr id="7" name="TextBox 6"/>
           <p:cNvSpPr txBox="1"/>
           <p:nvPr/>
         </p:nvSpPr>
@@ -10935,7 +11199,7 @@
       </p:sp>
       <p:sp>
         <p:nvSpPr>
-          <p:cNvPr id="7" name="TextBox 6"/>
+          <p:cNvPr id="8" name="TextBox 7"/>
           <p:cNvSpPr txBox="1"/>
           <p:nvPr/>
         </p:nvSpPr>
@@ -11640,16 +11904,40 @@
           </a:p>
         </p:txBody>
       </p:sp>
-      <p:sp>
-        <p:nvSpPr>
-          <p:cNvPr id="5" name="TextBox 4"/>
-          <p:cNvSpPr txBox="1"/>
-          <p:nvPr/>
-        </p:nvSpPr>
-        <p:spPr>
-          <a:xfrm>
-            <a:off x="731520" y="1371600"/>
-            <a:ext cx="10698480" cy="5029200"/>
+      <p:pic>
+        <p:nvPicPr>
+          <p:cNvPr id="5" name="Picture 4" descr="users.png"/>
+          <p:cNvPicPr>
+            <a:picLocks noChangeAspect="1"/>
+          </p:cNvPicPr>
+          <p:nvPr/>
+        </p:nvPicPr>
+        <p:blipFill>
+          <a:blip r:embed="rId2"/>
+          <a:stretch>
+            <a:fillRect/>
+          </a:stretch>
+        </p:blipFill>
+        <p:spPr>
+          <a:xfrm>
+            <a:off x="274320" y="1234440"/>
+            <a:ext cx="6858000" cy="5303520"/>
+          </a:xfrm>
+          <a:prstGeom prst="rect">
+            <a:avLst/>
+          </a:prstGeom>
+        </p:spPr>
+      </p:pic>
+      <p:sp>
+        <p:nvSpPr>
+          <p:cNvPr id="6" name="TextBox 5"/>
+          <p:cNvSpPr txBox="1"/>
+          <p:nvPr/>
+        </p:nvSpPr>
+        <p:spPr>
+          <a:xfrm>
+            <a:off x="7315200" y="1234440"/>
+            <a:ext cx="4572000" cy="5303520"/>
           </a:xfrm>
           <a:prstGeom prst="rect">
             <a:avLst/>
@@ -11664,9 +11952,9 @@
           <a:p>
             <a:pPr>
               <a:lnSpc>
-                <a:spcPts val="1900"/>
+                <a:spcPts val="1800"/>
               </a:lnSpc>
-              <a:defRPr sz="1300">
+              <a:defRPr sz="1200">
                 <a:solidFill>
                   <a:srgbClr val="0F172A"/>
                 </a:solidFill>
@@ -11744,7 +12032,7 @@
       </p:sp>
       <p:sp>
         <p:nvSpPr>
-          <p:cNvPr id="6" name="TextBox 5"/>
+          <p:cNvPr id="7" name="TextBox 6"/>
           <p:cNvSpPr txBox="1"/>
           <p:nvPr/>
         </p:nvSpPr>
@@ -11779,7 +12067,7 @@
       </p:sp>
       <p:sp>
         <p:nvSpPr>
-          <p:cNvPr id="7" name="TextBox 6"/>
+          <p:cNvPr id="8" name="TextBox 7"/>
           <p:cNvSpPr txBox="1"/>
           <p:nvPr/>
         </p:nvSpPr>
@@ -11951,16 +12239,40 @@
           </a:p>
         </p:txBody>
       </p:sp>
-      <p:sp>
-        <p:nvSpPr>
-          <p:cNvPr id="5" name="TextBox 4"/>
-          <p:cNvSpPr txBox="1"/>
-          <p:nvPr/>
-        </p:nvSpPr>
-        <p:spPr>
-          <a:xfrm>
-            <a:off x="731520" y="1371600"/>
-            <a:ext cx="10698480" cy="5029200"/>
+      <p:pic>
+        <p:nvPicPr>
+          <p:cNvPr id="5" name="Picture 4" descr="config.png"/>
+          <p:cNvPicPr>
+            <a:picLocks noChangeAspect="1"/>
+          </p:cNvPicPr>
+          <p:nvPr/>
+        </p:nvPicPr>
+        <p:blipFill>
+          <a:blip r:embed="rId2"/>
+          <a:stretch>
+            <a:fillRect/>
+          </a:stretch>
+        </p:blipFill>
+        <p:spPr>
+          <a:xfrm>
+            <a:off x="274320" y="1234440"/>
+            <a:ext cx="6858000" cy="5303520"/>
+          </a:xfrm>
+          <a:prstGeom prst="rect">
+            <a:avLst/>
+          </a:prstGeom>
+        </p:spPr>
+      </p:pic>
+      <p:sp>
+        <p:nvSpPr>
+          <p:cNvPr id="6" name="TextBox 5"/>
+          <p:cNvSpPr txBox="1"/>
+          <p:nvPr/>
+        </p:nvSpPr>
+        <p:spPr>
+          <a:xfrm>
+            <a:off x="7315200" y="1234440"/>
+            <a:ext cx="4572000" cy="5303520"/>
           </a:xfrm>
           <a:prstGeom prst="rect">
             <a:avLst/>
@@ -11975,9 +12287,9 @@
           <a:p>
             <a:pPr>
               <a:lnSpc>
-                <a:spcPts val="1900"/>
+                <a:spcPts val="1800"/>
               </a:lnSpc>
-              <a:defRPr sz="1300">
+              <a:defRPr sz="1200">
                 <a:solidFill>
                   <a:srgbClr val="0F172A"/>
                 </a:solidFill>
@@ -12059,7 +12371,7 @@
       </p:sp>
       <p:sp>
         <p:nvSpPr>
-          <p:cNvPr id="6" name="TextBox 5"/>
+          <p:cNvPr id="7" name="TextBox 6"/>
           <p:cNvSpPr txBox="1"/>
           <p:nvPr/>
         </p:nvSpPr>
@@ -12094,7 +12406,7 @@
       </p:sp>
       <p:sp>
         <p:nvSpPr>
-          <p:cNvPr id="7" name="TextBox 6"/>
+          <p:cNvPr id="8" name="TextBox 7"/>
           <p:cNvSpPr txBox="1"/>
           <p:nvPr/>
         </p:nvSpPr>
@@ -13735,16 +14047,40 @@
           </a:p>
         </p:txBody>
       </p:sp>
-      <p:sp>
-        <p:nvSpPr>
-          <p:cNvPr id="5" name="TextBox 4"/>
-          <p:cNvSpPr txBox="1"/>
-          <p:nvPr/>
-        </p:nvSpPr>
-        <p:spPr>
-          <a:xfrm>
-            <a:off x="731520" y="1371600"/>
-            <a:ext cx="10698480" cy="5029200"/>
+      <p:pic>
+        <p:nvPicPr>
+          <p:cNvPr id="5" name="Picture 4" descr="users.png"/>
+          <p:cNvPicPr>
+            <a:picLocks noChangeAspect="1"/>
+          </p:cNvPicPr>
+          <p:nvPr/>
+        </p:nvPicPr>
+        <p:blipFill>
+          <a:blip r:embed="rId2"/>
+          <a:stretch>
+            <a:fillRect/>
+          </a:stretch>
+        </p:blipFill>
+        <p:spPr>
+          <a:xfrm>
+            <a:off x="274320" y="1234440"/>
+            <a:ext cx="6858000" cy="5303520"/>
+          </a:xfrm>
+          <a:prstGeom prst="rect">
+            <a:avLst/>
+          </a:prstGeom>
+        </p:spPr>
+      </p:pic>
+      <p:sp>
+        <p:nvSpPr>
+          <p:cNvPr id="6" name="TextBox 5"/>
+          <p:cNvSpPr txBox="1"/>
+          <p:nvPr/>
+        </p:nvSpPr>
+        <p:spPr>
+          <a:xfrm>
+            <a:off x="7315200" y="1234440"/>
+            <a:ext cx="4572000" cy="5303520"/>
           </a:xfrm>
           <a:prstGeom prst="rect">
             <a:avLst/>
@@ -13759,9 +14095,9 @@
           <a:p>
             <a:pPr>
               <a:lnSpc>
-                <a:spcPts val="1900"/>
+                <a:spcPts val="1800"/>
               </a:lnSpc>
-              <a:defRPr sz="1300">
+              <a:defRPr sz="1200">
                 <a:solidFill>
                   <a:srgbClr val="0F172A"/>
                 </a:solidFill>
@@ -13842,7 +14178,7 @@
       </p:sp>
       <p:sp>
         <p:nvSpPr>
-          <p:cNvPr id="6" name="TextBox 5"/>
+          <p:cNvPr id="7" name="TextBox 6"/>
           <p:cNvSpPr txBox="1"/>
           <p:nvPr/>
         </p:nvSpPr>
@@ -13877,7 +14213,7 @@
       </p:sp>
       <p:sp>
         <p:nvSpPr>
-          <p:cNvPr id="7" name="TextBox 6"/>
+          <p:cNvPr id="8" name="TextBox 7"/>
           <p:cNvSpPr txBox="1"/>
           <p:nvPr/>
         </p:nvSpPr>

</xml_diff>